<commit_message>
Add poetic examples slide (slide 5) to Raudra Rasa PPTX
Agent-Logs-Url: https://github.com/nishant9414/Academics/sessions/8ac3eebc-255c-4ce3-8089-3bd9778ab200

Co-authored-by: nishant9414 <270184946+nishant9414@users.noreply.github.com>
</commit_message>
<xml_diff>
--- a/Raudra_Rasa_Presentation.pptx
+++ b/Raudra_Rasa_Presentation.pptx
@@ -9,6 +9,7 @@
     <p:sldId id="257" r:id="rId8"/>
     <p:sldId id="258" r:id="rId9"/>
     <p:sldId id="259" r:id="rId10"/>
+    <p:sldId id="268" r:id="rId19"/>
     <p:sldId id="260" r:id="rId11"/>
     <p:sldId id="261" r:id="rId12"/>
     <p:sldId id="262" r:id="rId13"/>
@@ -6368,6 +6369,1554 @@
                 </a:solidFill>
               </a:rPr>
               <a:t>Images: Wikimedia Commons, Unsplash, Pexels (free use)  |  Video: YouTube</a:t>
+            </a:r>
+          </a:p>
+        </p:txBody>
+      </p:sp>
+    </p:spTree>
+  </p:cSld>
+  <p:clrMapOvr>
+    <a:masterClrMapping/>
+  </p:clrMapOvr>
+</p:sld>
+</file>
+
+<file path=ppt/slides/slide13.xml><?xml version="1.0" encoding="utf-8"?>
+<p:sld xmlns:a="http://schemas.openxmlformats.org/drawingml/2006/main" xmlns:p="http://schemas.openxmlformats.org/presentationml/2006/main" xmlns:r="http://schemas.openxmlformats.org/officeDocument/2006/relationships">
+  <p:cSld>
+    <p:bg>
+      <p:bgPr>
+        <a:solidFill>
+          <a:srgbClr val="1A0000"/>
+        </a:solidFill>
+        <a:effectLst/>
+      </p:bgPr>
+    </p:bg>
+    <p:spTree>
+      <p:nvGrpSpPr>
+        <p:cNvPr id="1" name=""/>
+        <p:cNvGrpSpPr/>
+        <p:nvPr/>
+      </p:nvGrpSpPr>
+      <p:grpSpPr/>
+      <p:sp>
+        <p:nvSpPr>
+          <p:cNvPr id="2" name="Rectangle 1"/>
+          <p:cNvSpPr/>
+          <p:nvPr/>
+        </p:nvSpPr>
+        <p:spPr>
+          <a:xfrm>
+            <a:off x="0" y="0"/>
+            <a:ext cx="12188952" cy="502920"/>
+          </a:xfrm>
+          <a:prstGeom prst="rect">
+            <a:avLst/>
+          </a:prstGeom>
+          <a:solidFill>
+            <a:srgbClr val="B20000"/>
+          </a:solidFill>
+          <a:ln>
+            <a:noFill/>
+          </a:ln>
+        </p:spPr>
+        <p:style>
+          <a:lnRef idx="1">
+            <a:schemeClr val="accent1"/>
+          </a:lnRef>
+          <a:fillRef idx="3">
+            <a:schemeClr val="accent1"/>
+          </a:fillRef>
+          <a:effectRef idx="2">
+            <a:schemeClr val="accent1"/>
+          </a:effectRef>
+          <a:fontRef idx="minor">
+            <a:schemeClr val="lt1"/>
+          </a:fontRef>
+        </p:style>
+        <p:txBody>
+          <a:bodyPr rtlCol="0" anchor="ctr"/>
+          <a:lstStyle/>
+          <a:p>
+            <a:pPr algn="ctr"/>
+          </a:p>
+        </p:txBody>
+      </p:sp>
+      <p:sp>
+        <p:nvSpPr>
+          <p:cNvPr id="3" name="TextBox 2"/>
+          <p:cNvSpPr txBox="1"/>
+          <p:nvPr/>
+        </p:nvSpPr>
+        <p:spPr>
+          <a:xfrm>
+            <a:off x="365760" y="73152"/>
+            <a:ext cx="11430000" cy="457200"/>
+          </a:xfrm>
+          <a:prstGeom prst="rect">
+            <a:avLst/>
+          </a:prstGeom>
+          <a:noFill/>
+        </p:spPr>
+        <p:txBody>
+          <a:bodyPr wrap="none">
+            <a:spAutoFit/>
+          </a:bodyPr>
+          <a:lstStyle/>
+          <a:p>
+            <a:pPr algn="l"/>
+            <a:r>
+              <a:rPr sz="2100" b="1" i="0">
+                <a:solidFill>
+                  <a:srgbClr val="FFFFFF"/>
+                </a:solidFill>
+              </a:rPr>
+              <a:t>📜  POETIC EXAMPLES OF RAUDRA RASA</a:t>
+            </a:r>
+          </a:p>
+        </p:txBody>
+      </p:sp>
+      <p:sp>
+        <p:nvSpPr>
+          <p:cNvPr id="4" name="Rectangle 3"/>
+          <p:cNvSpPr/>
+          <p:nvPr/>
+        </p:nvSpPr>
+        <p:spPr>
+          <a:xfrm>
+            <a:off x="457200" y="576072"/>
+            <a:ext cx="11274552" cy="36576"/>
+          </a:xfrm>
+          <a:prstGeom prst="rect">
+            <a:avLst/>
+          </a:prstGeom>
+          <a:solidFill>
+            <a:srgbClr val="B20000"/>
+          </a:solidFill>
+          <a:ln>
+            <a:noFill/>
+          </a:ln>
+        </p:spPr>
+        <p:style>
+          <a:lnRef idx="1">
+            <a:schemeClr val="accent1"/>
+          </a:lnRef>
+          <a:fillRef idx="3">
+            <a:schemeClr val="accent1"/>
+          </a:fillRef>
+          <a:effectRef idx="2">
+            <a:schemeClr val="accent1"/>
+          </a:effectRef>
+          <a:fontRef idx="minor">
+            <a:schemeClr val="lt1"/>
+          </a:fontRef>
+        </p:style>
+        <p:txBody>
+          <a:bodyPr rtlCol="0" anchor="ctr"/>
+          <a:lstStyle/>
+          <a:p>
+            <a:pPr algn="ctr"/>
+          </a:p>
+        </p:txBody>
+      </p:sp>
+      <p:sp>
+        <p:nvSpPr>
+          <p:cNvPr id="5" name="TextBox 4"/>
+          <p:cNvSpPr txBox="1"/>
+          <p:nvPr/>
+        </p:nvSpPr>
+        <p:spPr>
+          <a:xfrm>
+            <a:off x="365760" y="612648"/>
+            <a:ext cx="11430000" cy="347472"/>
+          </a:xfrm>
+          <a:prstGeom prst="rect">
+            <a:avLst/>
+          </a:prstGeom>
+          <a:noFill/>
+        </p:spPr>
+        <p:txBody>
+          <a:bodyPr wrap="none">
+            <a:spAutoFit/>
+          </a:bodyPr>
+          <a:lstStyle/>
+          <a:p>
+            <a:pPr algn="l"/>
+            <a:r>
+              <a:rPr sz="1300" b="0" i="1">
+                <a:solidFill>
+                  <a:srgbClr val="CCCCCC"/>
+                </a:solidFill>
+              </a:rPr>
+              <a:t>Classical Sanskrit / Hindi poems where Raudra Rasa is at its peak  (original + simple English meaning)</a:t>
+            </a:r>
+          </a:p>
+        </p:txBody>
+      </p:sp>
+      <p:sp>
+        <p:nvSpPr>
+          <p:cNvPr id="6" name="Rectangle 5"/>
+          <p:cNvSpPr/>
+          <p:nvPr/>
+        </p:nvSpPr>
+        <p:spPr>
+          <a:xfrm>
+            <a:off x="228600" y="1005840"/>
+            <a:ext cx="5715000" cy="1920240"/>
+          </a:xfrm>
+          <a:prstGeom prst="rect">
+            <a:avLst/>
+          </a:prstGeom>
+          <a:solidFill>
+            <a:srgbClr val="2B0000"/>
+          </a:solidFill>
+          <a:ln>
+            <a:noFill/>
+          </a:ln>
+        </p:spPr>
+        <p:style>
+          <a:lnRef idx="1">
+            <a:schemeClr val="accent1"/>
+          </a:lnRef>
+          <a:fillRef idx="3">
+            <a:schemeClr val="accent1"/>
+          </a:fillRef>
+          <a:effectRef idx="2">
+            <a:schemeClr val="accent1"/>
+          </a:effectRef>
+          <a:fontRef idx="minor">
+            <a:schemeClr val="lt1"/>
+          </a:fontRef>
+        </p:style>
+        <p:txBody>
+          <a:bodyPr rtlCol="0" anchor="ctr"/>
+          <a:lstStyle/>
+          <a:p>
+            <a:pPr algn="ctr"/>
+          </a:p>
+        </p:txBody>
+      </p:sp>
+      <p:sp>
+        <p:nvSpPr>
+          <p:cNvPr id="7" name="Rectangle 6"/>
+          <p:cNvSpPr/>
+          <p:nvPr/>
+        </p:nvSpPr>
+        <p:spPr>
+          <a:xfrm>
+            <a:off x="228600" y="1005840"/>
+            <a:ext cx="54864" cy="1920240"/>
+          </a:xfrm>
+          <a:prstGeom prst="rect">
+            <a:avLst/>
+          </a:prstGeom>
+          <a:solidFill>
+            <a:srgbClr val="B20000"/>
+          </a:solidFill>
+          <a:ln>
+            <a:noFill/>
+          </a:ln>
+        </p:spPr>
+        <p:style>
+          <a:lnRef idx="1">
+            <a:schemeClr val="accent1"/>
+          </a:lnRef>
+          <a:fillRef idx="3">
+            <a:schemeClr val="accent1"/>
+          </a:fillRef>
+          <a:effectRef idx="2">
+            <a:schemeClr val="accent1"/>
+          </a:effectRef>
+          <a:fontRef idx="minor">
+            <a:schemeClr val="lt1"/>
+          </a:fontRef>
+        </p:style>
+        <p:txBody>
+          <a:bodyPr rtlCol="0" anchor="ctr"/>
+          <a:lstStyle/>
+          <a:p>
+            <a:pPr algn="ctr"/>
+          </a:p>
+        </p:txBody>
+      </p:sp>
+      <p:sp>
+        <p:nvSpPr>
+          <p:cNvPr id="8" name="TextBox 7"/>
+          <p:cNvSpPr txBox="1"/>
+          <p:nvPr/>
+        </p:nvSpPr>
+        <p:spPr>
+          <a:xfrm>
+            <a:off x="365760" y="1060704"/>
+            <a:ext cx="5532120" cy="274320"/>
+          </a:xfrm>
+          <a:prstGeom prst="rect">
+            <a:avLst/>
+          </a:prstGeom>
+          <a:noFill/>
+        </p:spPr>
+        <p:txBody>
+          <a:bodyPr wrap="none">
+            <a:spAutoFit/>
+          </a:bodyPr>
+          <a:lstStyle/>
+          <a:p>
+            <a:pPr algn="l"/>
+            <a:r>
+              <a:rPr sz="1000" b="1" i="1">
+                <a:solidFill>
+                  <a:srgbClr val="FF9900"/>
+                </a:solidFill>
+              </a:rPr>
+              <a:t>Mahabharata — Karna's Vow  (Sanskrit)</a:t>
+            </a:r>
+          </a:p>
+        </p:txBody>
+      </p:sp>
+      <p:sp>
+        <p:nvSpPr>
+          <p:cNvPr id="9" name="TextBox 8"/>
+          <p:cNvSpPr txBox="1"/>
+          <p:nvPr/>
+        </p:nvSpPr>
+        <p:spPr>
+          <a:xfrm>
+            <a:off x="365760" y="1316736"/>
+            <a:ext cx="2743200" cy="1508760"/>
+          </a:xfrm>
+          <a:prstGeom prst="rect">
+            <a:avLst/>
+          </a:prstGeom>
+          <a:noFill/>
+        </p:spPr>
+        <p:txBody>
+          <a:bodyPr wrap="square">
+            <a:spAutoFit/>
+          </a:bodyPr>
+          <a:lstStyle/>
+          <a:p>
+            <a:pPr algn="l"/>
+            <a:r>
+              <a:rPr sz="1050" b="0" i="1">
+                <a:solidFill>
+                  <a:srgbClr val="FFE080"/>
+                </a:solidFill>
+              </a:rPr>
+              <a:t>"अर्जुन, युद्ध में मैं तुझे देखूँगा,
+ और वह दिन तेरे लिए अंतिम होगा।"</a:t>
+            </a:r>
+          </a:p>
+        </p:txBody>
+      </p:sp>
+      <p:sp>
+        <p:nvSpPr>
+          <p:cNvPr id="10" name="TextBox 9"/>
+          <p:cNvSpPr txBox="1"/>
+          <p:nvPr/>
+        </p:nvSpPr>
+        <p:spPr>
+          <a:xfrm>
+            <a:off x="3108960" y="1316736"/>
+            <a:ext cx="2000250" cy="1508760"/>
+          </a:xfrm>
+          <a:prstGeom prst="rect">
+            <a:avLst/>
+          </a:prstGeom>
+          <a:noFill/>
+        </p:spPr>
+        <p:txBody>
+          <a:bodyPr wrap="square">
+            <a:spAutoFit/>
+          </a:bodyPr>
+          <a:lstStyle/>
+          <a:p>
+            <a:pPr algn="l"/>
+            <a:r>
+              <a:rPr sz="1000" b="0" i="1">
+                <a:solidFill>
+                  <a:srgbClr val="DDDDDD"/>
+                </a:solidFill>
+              </a:rPr>
+              <a:t>"Arjuna, on the battlefield I will face you,
+ and that day shall be your last."</a:t>
+            </a:r>
+          </a:p>
+        </p:txBody>
+      </p:sp>
+      <p:sp>
+        <p:nvSpPr>
+          <p:cNvPr id="11" name="TextBox 10"/>
+          <p:cNvSpPr txBox="1"/>
+          <p:nvPr/>
+        </p:nvSpPr>
+        <p:spPr>
+          <a:xfrm>
+            <a:off x="5143500" y="1316736"/>
+            <a:ext cx="754380" cy="1508760"/>
+          </a:xfrm>
+          <a:prstGeom prst="rect">
+            <a:avLst/>
+          </a:prstGeom>
+          <a:noFill/>
+        </p:spPr>
+        <p:txBody>
+          <a:bodyPr wrap="square">
+            <a:spAutoFit/>
+          </a:bodyPr>
+          <a:lstStyle/>
+          <a:p>
+            <a:pPr algn="l"/>
+            <a:r>
+              <a:rPr sz="850" b="0" i="0">
+                <a:solidFill>
+                  <a:srgbClr val="BBBBBB"/>
+                </a:solidFill>
+              </a:rPr>
+              <a:t>Short, direct, no decoration.
+Vow-structure = classic Raudra speech.
+Certainty of anger, not a question.</a:t>
+            </a:r>
+          </a:p>
+        </p:txBody>
+      </p:sp>
+      <p:sp>
+        <p:nvSpPr>
+          <p:cNvPr id="12" name="Rectangle 11"/>
+          <p:cNvSpPr/>
+          <p:nvPr/>
+        </p:nvSpPr>
+        <p:spPr>
+          <a:xfrm>
+            <a:off x="6126480" y="1005840"/>
+            <a:ext cx="5715000" cy="1920240"/>
+          </a:xfrm>
+          <a:prstGeom prst="rect">
+            <a:avLst/>
+          </a:prstGeom>
+          <a:solidFill>
+            <a:srgbClr val="380500"/>
+          </a:solidFill>
+          <a:ln>
+            <a:noFill/>
+          </a:ln>
+        </p:spPr>
+        <p:style>
+          <a:lnRef idx="1">
+            <a:schemeClr val="accent1"/>
+          </a:lnRef>
+          <a:fillRef idx="3">
+            <a:schemeClr val="accent1"/>
+          </a:fillRef>
+          <a:effectRef idx="2">
+            <a:schemeClr val="accent1"/>
+          </a:effectRef>
+          <a:fontRef idx="minor">
+            <a:schemeClr val="lt1"/>
+          </a:fontRef>
+        </p:style>
+        <p:txBody>
+          <a:bodyPr rtlCol="0" anchor="ctr"/>
+          <a:lstStyle/>
+          <a:p>
+            <a:pPr algn="ctr"/>
+          </a:p>
+        </p:txBody>
+      </p:sp>
+      <p:sp>
+        <p:nvSpPr>
+          <p:cNvPr id="13" name="Rectangle 12"/>
+          <p:cNvSpPr/>
+          <p:nvPr/>
+        </p:nvSpPr>
+        <p:spPr>
+          <a:xfrm>
+            <a:off x="6126480" y="1005840"/>
+            <a:ext cx="54864" cy="1920240"/>
+          </a:xfrm>
+          <a:prstGeom prst="rect">
+            <a:avLst/>
+          </a:prstGeom>
+          <a:solidFill>
+            <a:srgbClr val="B20000"/>
+          </a:solidFill>
+          <a:ln>
+            <a:noFill/>
+          </a:ln>
+        </p:spPr>
+        <p:style>
+          <a:lnRef idx="1">
+            <a:schemeClr val="accent1"/>
+          </a:lnRef>
+          <a:fillRef idx="3">
+            <a:schemeClr val="accent1"/>
+          </a:fillRef>
+          <a:effectRef idx="2">
+            <a:schemeClr val="accent1"/>
+          </a:effectRef>
+          <a:fontRef idx="minor">
+            <a:schemeClr val="lt1"/>
+          </a:fontRef>
+        </p:style>
+        <p:txBody>
+          <a:bodyPr rtlCol="0" anchor="ctr"/>
+          <a:lstStyle/>
+          <a:p>
+            <a:pPr algn="ctr"/>
+          </a:p>
+        </p:txBody>
+      </p:sp>
+      <p:sp>
+        <p:nvSpPr>
+          <p:cNvPr id="14" name="TextBox 13"/>
+          <p:cNvSpPr txBox="1"/>
+          <p:nvPr/>
+        </p:nvSpPr>
+        <p:spPr>
+          <a:xfrm>
+            <a:off x="6263640" y="1060704"/>
+            <a:ext cx="5532120" cy="274320"/>
+          </a:xfrm>
+          <a:prstGeom prst="rect">
+            <a:avLst/>
+          </a:prstGeom>
+          <a:noFill/>
+        </p:spPr>
+        <p:txBody>
+          <a:bodyPr wrap="none">
+            <a:spAutoFit/>
+          </a:bodyPr>
+          <a:lstStyle/>
+          <a:p>
+            <a:pPr algn="l"/>
+            <a:r>
+              <a:rPr sz="1000" b="1" i="1">
+                <a:solidFill>
+                  <a:srgbClr val="FF9900"/>
+                </a:solidFill>
+              </a:rPr>
+              <a:t>Tulsidas — Ramcharitmanas (Hindi Awadhi)</a:t>
+            </a:r>
+          </a:p>
+        </p:txBody>
+      </p:sp>
+      <p:sp>
+        <p:nvSpPr>
+          <p:cNvPr id="15" name="TextBox 14"/>
+          <p:cNvSpPr txBox="1"/>
+          <p:nvPr/>
+        </p:nvSpPr>
+        <p:spPr>
+          <a:xfrm>
+            <a:off x="6263640" y="1316736"/>
+            <a:ext cx="2743200" cy="1508760"/>
+          </a:xfrm>
+          <a:prstGeom prst="rect">
+            <a:avLst/>
+          </a:prstGeom>
+          <a:noFill/>
+        </p:spPr>
+        <p:txBody>
+          <a:bodyPr wrap="square">
+            <a:spAutoFit/>
+          </a:bodyPr>
+          <a:lstStyle/>
+          <a:p>
+            <a:pPr algn="l"/>
+            <a:r>
+              <a:rPr sz="1050" b="0" i="1">
+                <a:solidFill>
+                  <a:srgbClr val="FFE080"/>
+                </a:solidFill>
+              </a:rPr>
+              <a:t>"क्रोध अगिनि सब जग जारे,
+ राम भजन बिनु कहा निस्तारे।"</a:t>
+            </a:r>
+          </a:p>
+        </p:txBody>
+      </p:sp>
+      <p:sp>
+        <p:nvSpPr>
+          <p:cNvPr id="16" name="TextBox 15"/>
+          <p:cNvSpPr txBox="1"/>
+          <p:nvPr/>
+        </p:nvSpPr>
+        <p:spPr>
+          <a:xfrm>
+            <a:off x="9006840" y="1316736"/>
+            <a:ext cx="2000250" cy="1508760"/>
+          </a:xfrm>
+          <a:prstGeom prst="rect">
+            <a:avLst/>
+          </a:prstGeom>
+          <a:noFill/>
+        </p:spPr>
+        <p:txBody>
+          <a:bodyPr wrap="square">
+            <a:spAutoFit/>
+          </a:bodyPr>
+          <a:lstStyle/>
+          <a:p>
+            <a:pPr algn="l"/>
+            <a:r>
+              <a:rPr sz="1000" b="0" i="1">
+                <a:solidFill>
+                  <a:srgbClr val="DDDDDD"/>
+                </a:solidFill>
+              </a:rPr>
+              <a:t>"The fire of anger burns the whole world —
+ without devotion to Ram, there is no escape."</a:t>
+            </a:r>
+          </a:p>
+        </p:txBody>
+      </p:sp>
+      <p:sp>
+        <p:nvSpPr>
+          <p:cNvPr id="17" name="TextBox 16"/>
+          <p:cNvSpPr txBox="1"/>
+          <p:nvPr/>
+        </p:nvSpPr>
+        <p:spPr>
+          <a:xfrm>
+            <a:off x="11041380" y="1316736"/>
+            <a:ext cx="754380" cy="1508760"/>
+          </a:xfrm>
+          <a:prstGeom prst="rect">
+            <a:avLst/>
+          </a:prstGeom>
+          <a:noFill/>
+        </p:spPr>
+        <p:txBody>
+          <a:bodyPr wrap="square">
+            <a:spAutoFit/>
+          </a:bodyPr>
+          <a:lstStyle/>
+          <a:p>
+            <a:pPr algn="l"/>
+            <a:r>
+              <a:rPr sz="850" b="0" i="0">
+                <a:solidFill>
+                  <a:srgbClr val="BBBBBB"/>
+                </a:solidFill>
+              </a:rPr>
+              <a:t>Fire metaphor = Raudra's symbol.
+Anger shown as destructive, universal.
+Moral warning embedded in Raudra.</a:t>
+            </a:r>
+          </a:p>
+        </p:txBody>
+      </p:sp>
+      <p:sp>
+        <p:nvSpPr>
+          <p:cNvPr id="18" name="Rectangle 17"/>
+          <p:cNvSpPr/>
+          <p:nvPr/>
+        </p:nvSpPr>
+        <p:spPr>
+          <a:xfrm>
+            <a:off x="228600" y="2999232"/>
+            <a:ext cx="5715000" cy="1920240"/>
+          </a:xfrm>
+          <a:prstGeom prst="rect">
+            <a:avLst/>
+          </a:prstGeom>
+          <a:solidFill>
+            <a:srgbClr val="2B0000"/>
+          </a:solidFill>
+          <a:ln>
+            <a:noFill/>
+          </a:ln>
+        </p:spPr>
+        <p:style>
+          <a:lnRef idx="1">
+            <a:schemeClr val="accent1"/>
+          </a:lnRef>
+          <a:fillRef idx="3">
+            <a:schemeClr val="accent1"/>
+          </a:fillRef>
+          <a:effectRef idx="2">
+            <a:schemeClr val="accent1"/>
+          </a:effectRef>
+          <a:fontRef idx="minor">
+            <a:schemeClr val="lt1"/>
+          </a:fontRef>
+        </p:style>
+        <p:txBody>
+          <a:bodyPr rtlCol="0" anchor="ctr"/>
+          <a:lstStyle/>
+          <a:p>
+            <a:pPr algn="ctr"/>
+          </a:p>
+        </p:txBody>
+      </p:sp>
+      <p:sp>
+        <p:nvSpPr>
+          <p:cNvPr id="19" name="Rectangle 18"/>
+          <p:cNvSpPr/>
+          <p:nvPr/>
+        </p:nvSpPr>
+        <p:spPr>
+          <a:xfrm>
+            <a:off x="228600" y="2999232"/>
+            <a:ext cx="54864" cy="1920240"/>
+          </a:xfrm>
+          <a:prstGeom prst="rect">
+            <a:avLst/>
+          </a:prstGeom>
+          <a:solidFill>
+            <a:srgbClr val="B20000"/>
+          </a:solidFill>
+          <a:ln>
+            <a:noFill/>
+          </a:ln>
+        </p:spPr>
+        <p:style>
+          <a:lnRef idx="1">
+            <a:schemeClr val="accent1"/>
+          </a:lnRef>
+          <a:fillRef idx="3">
+            <a:schemeClr val="accent1"/>
+          </a:fillRef>
+          <a:effectRef idx="2">
+            <a:schemeClr val="accent1"/>
+          </a:effectRef>
+          <a:fontRef idx="minor">
+            <a:schemeClr val="lt1"/>
+          </a:fontRef>
+        </p:style>
+        <p:txBody>
+          <a:bodyPr rtlCol="0" anchor="ctr"/>
+          <a:lstStyle/>
+          <a:p>
+            <a:pPr algn="ctr"/>
+          </a:p>
+        </p:txBody>
+      </p:sp>
+      <p:sp>
+        <p:nvSpPr>
+          <p:cNvPr id="20" name="TextBox 19"/>
+          <p:cNvSpPr txBox="1"/>
+          <p:nvPr/>
+        </p:nvSpPr>
+        <p:spPr>
+          <a:xfrm>
+            <a:off x="365760" y="3054096"/>
+            <a:ext cx="5532120" cy="274320"/>
+          </a:xfrm>
+          <a:prstGeom prst="rect">
+            <a:avLst/>
+          </a:prstGeom>
+          <a:noFill/>
+        </p:spPr>
+        <p:txBody>
+          <a:bodyPr wrap="none">
+            <a:spAutoFit/>
+          </a:bodyPr>
+          <a:lstStyle/>
+          <a:p>
+            <a:pPr algn="l"/>
+            <a:r>
+              <a:rPr sz="1000" b="1" i="1">
+                <a:solidFill>
+                  <a:srgbClr val="FF9900"/>
+                </a:solidFill>
+              </a:rPr>
+              <a:t>Harivansh Rai Bachchan — Madhushala (Hindi)</a:t>
+            </a:r>
+          </a:p>
+        </p:txBody>
+      </p:sp>
+      <p:sp>
+        <p:nvSpPr>
+          <p:cNvPr id="21" name="TextBox 20"/>
+          <p:cNvSpPr txBox="1"/>
+          <p:nvPr/>
+        </p:nvSpPr>
+        <p:spPr>
+          <a:xfrm>
+            <a:off x="365760" y="3310127"/>
+            <a:ext cx="2743200" cy="1508760"/>
+          </a:xfrm>
+          <a:prstGeom prst="rect">
+            <a:avLst/>
+          </a:prstGeom>
+          <a:noFill/>
+        </p:spPr>
+        <p:txBody>
+          <a:bodyPr wrap="square">
+            <a:spAutoFit/>
+          </a:bodyPr>
+          <a:lstStyle/>
+          <a:p>
+            <a:pPr algn="l"/>
+            <a:r>
+              <a:rPr sz="1050" b="0" i="1">
+                <a:solidFill>
+                  <a:srgbClr val="FFE080"/>
+                </a:solidFill>
+              </a:rPr>
+              <a:t>"जो हाला मैंने माँगी थी,
+ वह किसी और को दे दी —
+ यह अन्याय मेरी रग-रग में
+ आग बन कर जल उठी।"</a:t>
+            </a:r>
+          </a:p>
+        </p:txBody>
+      </p:sp>
+      <p:sp>
+        <p:nvSpPr>
+          <p:cNvPr id="22" name="TextBox 21"/>
+          <p:cNvSpPr txBox="1"/>
+          <p:nvPr/>
+        </p:nvSpPr>
+        <p:spPr>
+          <a:xfrm>
+            <a:off x="3108960" y="3310127"/>
+            <a:ext cx="2000250" cy="1508760"/>
+          </a:xfrm>
+          <a:prstGeom prst="rect">
+            <a:avLst/>
+          </a:prstGeom>
+          <a:noFill/>
+        </p:spPr>
+        <p:txBody>
+          <a:bodyPr wrap="square">
+            <a:spAutoFit/>
+          </a:bodyPr>
+          <a:lstStyle/>
+          <a:p>
+            <a:pPr algn="l"/>
+            <a:r>
+              <a:rPr sz="1000" b="0" i="1">
+                <a:solidFill>
+                  <a:srgbClr val="DDDDDD"/>
+                </a:solidFill>
+              </a:rPr>
+              <a:t>"The wine I had asked for
+ was given to someone else —
+ this injustice set every vein in me
+ ablaze with fire."</a:t>
+            </a:r>
+          </a:p>
+        </p:txBody>
+      </p:sp>
+      <p:sp>
+        <p:nvSpPr>
+          <p:cNvPr id="23" name="TextBox 22"/>
+          <p:cNvSpPr txBox="1"/>
+          <p:nvPr/>
+        </p:nvSpPr>
+        <p:spPr>
+          <a:xfrm>
+            <a:off x="5143500" y="3310127"/>
+            <a:ext cx="754380" cy="1508760"/>
+          </a:xfrm>
+          <a:prstGeom prst="rect">
+            <a:avLst/>
+          </a:prstGeom>
+          <a:noFill/>
+        </p:spPr>
+        <p:txBody>
+          <a:bodyPr wrap="square">
+            <a:spAutoFit/>
+          </a:bodyPr>
+          <a:lstStyle/>
+          <a:p>
+            <a:pPr algn="l"/>
+            <a:r>
+              <a:rPr sz="850" b="0" i="0">
+                <a:solidFill>
+                  <a:srgbClr val="BBBBBB"/>
+                </a:solidFill>
+              </a:rPr>
+              <a:t>Betrayal → anger = classic Raudra trigger.
+'Rag-rag mein aag' = body-level rage.
+Internal Raudra, not physical violence.</a:t>
+            </a:r>
+          </a:p>
+        </p:txBody>
+      </p:sp>
+      <p:sp>
+        <p:nvSpPr>
+          <p:cNvPr id="24" name="Rectangle 23"/>
+          <p:cNvSpPr/>
+          <p:nvPr/>
+        </p:nvSpPr>
+        <p:spPr>
+          <a:xfrm>
+            <a:off x="6126480" y="2999232"/>
+            <a:ext cx="5715000" cy="1920240"/>
+          </a:xfrm>
+          <a:prstGeom prst="rect">
+            <a:avLst/>
+          </a:prstGeom>
+          <a:solidFill>
+            <a:srgbClr val="380500"/>
+          </a:solidFill>
+          <a:ln>
+            <a:noFill/>
+          </a:ln>
+        </p:spPr>
+        <p:style>
+          <a:lnRef idx="1">
+            <a:schemeClr val="accent1"/>
+          </a:lnRef>
+          <a:fillRef idx="3">
+            <a:schemeClr val="accent1"/>
+          </a:fillRef>
+          <a:effectRef idx="2">
+            <a:schemeClr val="accent1"/>
+          </a:effectRef>
+          <a:fontRef idx="minor">
+            <a:schemeClr val="lt1"/>
+          </a:fontRef>
+        </p:style>
+        <p:txBody>
+          <a:bodyPr rtlCol="0" anchor="ctr"/>
+          <a:lstStyle/>
+          <a:p>
+            <a:pPr algn="ctr"/>
+          </a:p>
+        </p:txBody>
+      </p:sp>
+      <p:sp>
+        <p:nvSpPr>
+          <p:cNvPr id="25" name="Rectangle 24"/>
+          <p:cNvSpPr/>
+          <p:nvPr/>
+        </p:nvSpPr>
+        <p:spPr>
+          <a:xfrm>
+            <a:off x="6126480" y="2999232"/>
+            <a:ext cx="54864" cy="1920240"/>
+          </a:xfrm>
+          <a:prstGeom prst="rect">
+            <a:avLst/>
+          </a:prstGeom>
+          <a:solidFill>
+            <a:srgbClr val="B20000"/>
+          </a:solidFill>
+          <a:ln>
+            <a:noFill/>
+          </a:ln>
+        </p:spPr>
+        <p:style>
+          <a:lnRef idx="1">
+            <a:schemeClr val="accent1"/>
+          </a:lnRef>
+          <a:fillRef idx="3">
+            <a:schemeClr val="accent1"/>
+          </a:fillRef>
+          <a:effectRef idx="2">
+            <a:schemeClr val="accent1"/>
+          </a:effectRef>
+          <a:fontRef idx="minor">
+            <a:schemeClr val="lt1"/>
+          </a:fontRef>
+        </p:style>
+        <p:txBody>
+          <a:bodyPr rtlCol="0" anchor="ctr"/>
+          <a:lstStyle/>
+          <a:p>
+            <a:pPr algn="ctr"/>
+          </a:p>
+        </p:txBody>
+      </p:sp>
+      <p:sp>
+        <p:nvSpPr>
+          <p:cNvPr id="26" name="TextBox 25"/>
+          <p:cNvSpPr txBox="1"/>
+          <p:nvPr/>
+        </p:nvSpPr>
+        <p:spPr>
+          <a:xfrm>
+            <a:off x="6263640" y="3054096"/>
+            <a:ext cx="5532120" cy="274320"/>
+          </a:xfrm>
+          <a:prstGeom prst="rect">
+            <a:avLst/>
+          </a:prstGeom>
+          <a:noFill/>
+        </p:spPr>
+        <p:txBody>
+          <a:bodyPr wrap="none">
+            <a:spAutoFit/>
+          </a:bodyPr>
+          <a:lstStyle/>
+          <a:p>
+            <a:pPr algn="l"/>
+            <a:r>
+              <a:rPr sz="1000" b="1" i="1">
+                <a:solidFill>
+                  <a:srgbClr val="FF9900"/>
+                </a:solidFill>
+              </a:rPr>
+              <a:t>Ramdhari Singh Dinkar — Rashmirathi (Hindi Epic)</a:t>
+            </a:r>
+          </a:p>
+        </p:txBody>
+      </p:sp>
+      <p:sp>
+        <p:nvSpPr>
+          <p:cNvPr id="27" name="TextBox 26"/>
+          <p:cNvSpPr txBox="1"/>
+          <p:nvPr/>
+        </p:nvSpPr>
+        <p:spPr>
+          <a:xfrm>
+            <a:off x="6263640" y="3310127"/>
+            <a:ext cx="2743200" cy="1508760"/>
+          </a:xfrm>
+          <a:prstGeom prst="rect">
+            <a:avLst/>
+          </a:prstGeom>
+          <a:noFill/>
+        </p:spPr>
+        <p:txBody>
+          <a:bodyPr wrap="square">
+            <a:spAutoFit/>
+          </a:bodyPr>
+          <a:lstStyle/>
+          <a:p>
+            <a:pPr algn="l"/>
+            <a:r>
+              <a:rPr sz="1050" b="0" i="1">
+                <a:solidFill>
+                  <a:srgbClr val="FFE080"/>
+                </a:solidFill>
+              </a:rPr>
+              <a:t>"जला अस्थियाँ बारे नभ में
+ चिनगारियाँ उड़ाता हूँ,
+ पाँचों महाभूतों में भी
+ अपना हुंकार सुनाता हूँ।"</a:t>
+            </a:r>
+          </a:p>
+        </p:txBody>
+      </p:sp>
+      <p:sp>
+        <p:nvSpPr>
+          <p:cNvPr id="28" name="TextBox 27"/>
+          <p:cNvSpPr txBox="1"/>
+          <p:nvPr/>
+        </p:nvSpPr>
+        <p:spPr>
+          <a:xfrm>
+            <a:off x="9006840" y="3310127"/>
+            <a:ext cx="2000250" cy="1508760"/>
+          </a:xfrm>
+          <a:prstGeom prst="rect">
+            <a:avLst/>
+          </a:prstGeom>
+          <a:noFill/>
+        </p:spPr>
+        <p:txBody>
+          <a:bodyPr wrap="square">
+            <a:spAutoFit/>
+          </a:bodyPr>
+          <a:lstStyle/>
+          <a:p>
+            <a:pPr algn="l"/>
+            <a:r>
+              <a:rPr sz="1000" b="0" i="1">
+                <a:solidFill>
+                  <a:srgbClr val="DDDDDD"/>
+                </a:solidFill>
+              </a:rPr>
+              <a:t>"I burn bones and scatter sparks across the sky,
+ My roar echoes through all five elements."</a:t>
+            </a:r>
+          </a:p>
+        </p:txBody>
+      </p:sp>
+      <p:sp>
+        <p:nvSpPr>
+          <p:cNvPr id="29" name="TextBox 28"/>
+          <p:cNvSpPr txBox="1"/>
+          <p:nvPr/>
+        </p:nvSpPr>
+        <p:spPr>
+          <a:xfrm>
+            <a:off x="11041380" y="3310127"/>
+            <a:ext cx="754380" cy="1508760"/>
+          </a:xfrm>
+          <a:prstGeom prst="rect">
+            <a:avLst/>
+          </a:prstGeom>
+          <a:noFill/>
+        </p:spPr>
+        <p:txBody>
+          <a:bodyPr wrap="square">
+            <a:spAutoFit/>
+          </a:bodyPr>
+          <a:lstStyle/>
+          <a:p>
+            <a:pPr algn="l"/>
+            <a:r>
+              <a:rPr sz="850" b="0" i="0">
+                <a:solidFill>
+                  <a:srgbClr val="BBBBBB"/>
+                </a:solidFill>
+              </a:rPr>
+              <a:t>Rashmirathi = greatest modern Hindi Raudra poetry.
+Karna's fury against fate and injustice.
+Cosmic scale of anger — Raudra at its peak.</a:t>
+            </a:r>
+          </a:p>
+        </p:txBody>
+      </p:sp>
+      <p:sp>
+        <p:nvSpPr>
+          <p:cNvPr id="30" name="Rectangle 29"/>
+          <p:cNvSpPr/>
+          <p:nvPr/>
+        </p:nvSpPr>
+        <p:spPr>
+          <a:xfrm>
+            <a:off x="228600" y="4992624"/>
+            <a:ext cx="5715000" cy="1920240"/>
+          </a:xfrm>
+          <a:prstGeom prst="rect">
+            <a:avLst/>
+          </a:prstGeom>
+          <a:solidFill>
+            <a:srgbClr val="2B0000"/>
+          </a:solidFill>
+          <a:ln>
+            <a:noFill/>
+          </a:ln>
+        </p:spPr>
+        <p:style>
+          <a:lnRef idx="1">
+            <a:schemeClr val="accent1"/>
+          </a:lnRef>
+          <a:fillRef idx="3">
+            <a:schemeClr val="accent1"/>
+          </a:fillRef>
+          <a:effectRef idx="2">
+            <a:schemeClr val="accent1"/>
+          </a:effectRef>
+          <a:fontRef idx="minor">
+            <a:schemeClr val="lt1"/>
+          </a:fontRef>
+        </p:style>
+        <p:txBody>
+          <a:bodyPr rtlCol="0" anchor="ctr"/>
+          <a:lstStyle/>
+          <a:p>
+            <a:pPr algn="ctr"/>
+          </a:p>
+        </p:txBody>
+      </p:sp>
+      <p:sp>
+        <p:nvSpPr>
+          <p:cNvPr id="31" name="Rectangle 30"/>
+          <p:cNvSpPr/>
+          <p:nvPr/>
+        </p:nvSpPr>
+        <p:spPr>
+          <a:xfrm>
+            <a:off x="228600" y="4992624"/>
+            <a:ext cx="54864" cy="1920240"/>
+          </a:xfrm>
+          <a:prstGeom prst="rect">
+            <a:avLst/>
+          </a:prstGeom>
+          <a:solidFill>
+            <a:srgbClr val="B20000"/>
+          </a:solidFill>
+          <a:ln>
+            <a:noFill/>
+          </a:ln>
+        </p:spPr>
+        <p:style>
+          <a:lnRef idx="1">
+            <a:schemeClr val="accent1"/>
+          </a:lnRef>
+          <a:fillRef idx="3">
+            <a:schemeClr val="accent1"/>
+          </a:fillRef>
+          <a:effectRef idx="2">
+            <a:schemeClr val="accent1"/>
+          </a:effectRef>
+          <a:fontRef idx="minor">
+            <a:schemeClr val="lt1"/>
+          </a:fontRef>
+        </p:style>
+        <p:txBody>
+          <a:bodyPr rtlCol="0" anchor="ctr"/>
+          <a:lstStyle/>
+          <a:p>
+            <a:pPr algn="ctr"/>
+          </a:p>
+        </p:txBody>
+      </p:sp>
+      <p:sp>
+        <p:nvSpPr>
+          <p:cNvPr id="32" name="TextBox 31"/>
+          <p:cNvSpPr txBox="1"/>
+          <p:nvPr/>
+        </p:nvSpPr>
+        <p:spPr>
+          <a:xfrm>
+            <a:off x="365760" y="5047488"/>
+            <a:ext cx="5532120" cy="274320"/>
+          </a:xfrm>
+          <a:prstGeom prst="rect">
+            <a:avLst/>
+          </a:prstGeom>
+          <a:noFill/>
+        </p:spPr>
+        <p:txBody>
+          <a:bodyPr wrap="none">
+            <a:spAutoFit/>
+          </a:bodyPr>
+          <a:lstStyle/>
+          <a:p>
+            <a:pPr algn="l"/>
+            <a:r>
+              <a:rPr sz="1000" b="1" i="1">
+                <a:solidFill>
+                  <a:srgbClr val="FF9900"/>
+                </a:solidFill>
+              </a:rPr>
+              <a:t>Mirabai — Defiant Verse  (Rajasthani Hindi)</a:t>
+            </a:r>
+          </a:p>
+        </p:txBody>
+      </p:sp>
+      <p:sp>
+        <p:nvSpPr>
+          <p:cNvPr id="33" name="TextBox 32"/>
+          <p:cNvSpPr txBox="1"/>
+          <p:nvPr/>
+        </p:nvSpPr>
+        <p:spPr>
+          <a:xfrm>
+            <a:off x="365760" y="5303520"/>
+            <a:ext cx="2743200" cy="1508760"/>
+          </a:xfrm>
+          <a:prstGeom prst="rect">
+            <a:avLst/>
+          </a:prstGeom>
+          <a:noFill/>
+        </p:spPr>
+        <p:txBody>
+          <a:bodyPr wrap="square">
+            <a:spAutoFit/>
+          </a:bodyPr>
+          <a:lstStyle/>
+          <a:p>
+            <a:pPr algn="l"/>
+            <a:r>
+              <a:rPr sz="1050" b="0" i="1">
+                <a:solidFill>
+                  <a:srgbClr val="FFE080"/>
+                </a:solidFill>
+              </a:rPr>
+              <a:t>"राणा मैंने राम रतन धन पायो,
+ तेरी दुनिया से मुझे क्या लेना,
+ जो दे सकता है वो दे दे —
+ मेरा क्रोध अब तुझसे नहीं डरता।"</a:t>
+            </a:r>
+          </a:p>
+        </p:txBody>
+      </p:sp>
+      <p:sp>
+        <p:nvSpPr>
+          <p:cNvPr id="34" name="TextBox 33"/>
+          <p:cNvSpPr txBox="1"/>
+          <p:nvPr/>
+        </p:nvSpPr>
+        <p:spPr>
+          <a:xfrm>
+            <a:off x="3108960" y="5303520"/>
+            <a:ext cx="2000250" cy="1508760"/>
+          </a:xfrm>
+          <a:prstGeom prst="rect">
+            <a:avLst/>
+          </a:prstGeom>
+          <a:noFill/>
+        </p:spPr>
+        <p:txBody>
+          <a:bodyPr wrap="square">
+            <a:spAutoFit/>
+          </a:bodyPr>
+          <a:lstStyle/>
+          <a:p>
+            <a:pPr algn="l"/>
+            <a:r>
+              <a:rPr sz="1000" b="0" i="1">
+                <a:solidFill>
+                  <a:srgbClr val="DDDDDD"/>
+                </a:solidFill>
+              </a:rPr>
+              <a:t>"King, I have found the jewel of Ram.
+ I want nothing from your world.
+ Do what you will —
+ my anger no longer fears you."</a:t>
+            </a:r>
+          </a:p>
+        </p:txBody>
+      </p:sp>
+      <p:sp>
+        <p:nvSpPr>
+          <p:cNvPr id="35" name="TextBox 34"/>
+          <p:cNvSpPr txBox="1"/>
+          <p:nvPr/>
+        </p:nvSpPr>
+        <p:spPr>
+          <a:xfrm>
+            <a:off x="5143500" y="5303520"/>
+            <a:ext cx="754380" cy="1508760"/>
+          </a:xfrm>
+          <a:prstGeom prst="rect">
+            <a:avLst/>
+          </a:prstGeom>
+          <a:noFill/>
+        </p:spPr>
+        <p:txBody>
+          <a:bodyPr wrap="square">
+            <a:spAutoFit/>
+          </a:bodyPr>
+          <a:lstStyle/>
+          <a:p>
+            <a:pPr algn="l"/>
+            <a:r>
+              <a:rPr sz="850" b="0" i="0">
+                <a:solidFill>
+                  <a:srgbClr val="BBBBBB"/>
+                </a:solidFill>
+              </a:rPr>
+              <a:t>Righteous Raudra: fearless defiance against injustice.
+Quiet but absolute — anger through spiritual conviction.
+Shows Raudra can be calm, not just explosive.</a:t>
+            </a:r>
+          </a:p>
+        </p:txBody>
+      </p:sp>
+      <p:sp>
+        <p:nvSpPr>
+          <p:cNvPr id="36" name="Rectangle 35"/>
+          <p:cNvSpPr/>
+          <p:nvPr/>
+        </p:nvSpPr>
+        <p:spPr>
+          <a:xfrm>
+            <a:off x="6126480" y="4992624"/>
+            <a:ext cx="5715000" cy="1920240"/>
+          </a:xfrm>
+          <a:prstGeom prst="rect">
+            <a:avLst/>
+          </a:prstGeom>
+          <a:solidFill>
+            <a:srgbClr val="380500"/>
+          </a:solidFill>
+          <a:ln>
+            <a:noFill/>
+          </a:ln>
+        </p:spPr>
+        <p:style>
+          <a:lnRef idx="1">
+            <a:schemeClr val="accent1"/>
+          </a:lnRef>
+          <a:fillRef idx="3">
+            <a:schemeClr val="accent1"/>
+          </a:fillRef>
+          <a:effectRef idx="2">
+            <a:schemeClr val="accent1"/>
+          </a:effectRef>
+          <a:fontRef idx="minor">
+            <a:schemeClr val="lt1"/>
+          </a:fontRef>
+        </p:style>
+        <p:txBody>
+          <a:bodyPr rtlCol="0" anchor="ctr"/>
+          <a:lstStyle/>
+          <a:p>
+            <a:pPr algn="ctr"/>
+          </a:p>
+        </p:txBody>
+      </p:sp>
+      <p:sp>
+        <p:nvSpPr>
+          <p:cNvPr id="37" name="Rectangle 36"/>
+          <p:cNvSpPr/>
+          <p:nvPr/>
+        </p:nvSpPr>
+        <p:spPr>
+          <a:xfrm>
+            <a:off x="6126480" y="4992624"/>
+            <a:ext cx="54864" cy="1920240"/>
+          </a:xfrm>
+          <a:prstGeom prst="rect">
+            <a:avLst/>
+          </a:prstGeom>
+          <a:solidFill>
+            <a:srgbClr val="B20000"/>
+          </a:solidFill>
+          <a:ln>
+            <a:noFill/>
+          </a:ln>
+        </p:spPr>
+        <p:style>
+          <a:lnRef idx="1">
+            <a:schemeClr val="accent1"/>
+          </a:lnRef>
+          <a:fillRef idx="3">
+            <a:schemeClr val="accent1"/>
+          </a:fillRef>
+          <a:effectRef idx="2">
+            <a:schemeClr val="accent1"/>
+          </a:effectRef>
+          <a:fontRef idx="minor">
+            <a:schemeClr val="lt1"/>
+          </a:fontRef>
+        </p:style>
+        <p:txBody>
+          <a:bodyPr rtlCol="0" anchor="ctr"/>
+          <a:lstStyle/>
+          <a:p>
+            <a:pPr algn="ctr"/>
+          </a:p>
+        </p:txBody>
+      </p:sp>
+      <p:sp>
+        <p:nvSpPr>
+          <p:cNvPr id="38" name="TextBox 37"/>
+          <p:cNvSpPr txBox="1"/>
+          <p:nvPr/>
+        </p:nvSpPr>
+        <p:spPr>
+          <a:xfrm>
+            <a:off x="6263640" y="5047488"/>
+            <a:ext cx="5532120" cy="274320"/>
+          </a:xfrm>
+          <a:prstGeom prst="rect">
+            <a:avLst/>
+          </a:prstGeom>
+          <a:noFill/>
+        </p:spPr>
+        <p:txBody>
+          <a:bodyPr wrap="none">
+            <a:spAutoFit/>
+          </a:bodyPr>
+          <a:lstStyle/>
+          <a:p>
+            <a:pPr algn="l"/>
+            <a:r>
+              <a:rPr sz="1000" b="1" i="1">
+                <a:solidFill>
+                  <a:srgbClr val="FF9900"/>
+                </a:solidFill>
+              </a:rPr>
+              <a:t>Kabir Das — Doha  (15th century Hindi)</a:t>
+            </a:r>
+          </a:p>
+        </p:txBody>
+      </p:sp>
+      <p:sp>
+        <p:nvSpPr>
+          <p:cNvPr id="39" name="TextBox 38"/>
+          <p:cNvSpPr txBox="1"/>
+          <p:nvPr/>
+        </p:nvSpPr>
+        <p:spPr>
+          <a:xfrm>
+            <a:off x="6263640" y="5303520"/>
+            <a:ext cx="2743200" cy="1508760"/>
+          </a:xfrm>
+          <a:prstGeom prst="rect">
+            <a:avLst/>
+          </a:prstGeom>
+          <a:noFill/>
+        </p:spPr>
+        <p:txBody>
+          <a:bodyPr wrap="square">
+            <a:spAutoFit/>
+          </a:bodyPr>
+          <a:lstStyle/>
+          <a:p>
+            <a:pPr algn="l"/>
+            <a:r>
+              <a:rPr sz="1050" b="0" i="1">
+                <a:solidFill>
+                  <a:srgbClr val="FFE080"/>
+                </a:solidFill>
+              </a:rPr>
+              <a:t>"क्रोध को काटे ज्ञान की तलवार,
+ पर जो उठे अधर्म के विरुद्ध —
+ वह क्रोध धर्म की पुकार।"</a:t>
+            </a:r>
+          </a:p>
+        </p:txBody>
+      </p:sp>
+      <p:sp>
+        <p:nvSpPr>
+          <p:cNvPr id="40" name="TextBox 39"/>
+          <p:cNvSpPr txBox="1"/>
+          <p:nvPr/>
+        </p:nvSpPr>
+        <p:spPr>
+          <a:xfrm>
+            <a:off x="9006840" y="5303520"/>
+            <a:ext cx="2000250" cy="1508760"/>
+          </a:xfrm>
+          <a:prstGeom prst="rect">
+            <a:avLst/>
+          </a:prstGeom>
+          <a:noFill/>
+        </p:spPr>
+        <p:txBody>
+          <a:bodyPr wrap="square">
+            <a:spAutoFit/>
+          </a:bodyPr>
+          <a:lstStyle/>
+          <a:p>
+            <a:pPr algn="l"/>
+            <a:r>
+              <a:rPr sz="1000" b="0" i="1">
+                <a:solidFill>
+                  <a:srgbClr val="DDDDDD"/>
+                </a:solidFill>
+              </a:rPr>
+              <a:t>"Knowledge cuts anger like a sword,
+ But anger that rises against injustice —
+ that anger is the call of righteousness."</a:t>
+            </a:r>
+          </a:p>
+        </p:txBody>
+      </p:sp>
+      <p:sp>
+        <p:nvSpPr>
+          <p:cNvPr id="41" name="TextBox 40"/>
+          <p:cNvSpPr txBox="1"/>
+          <p:nvPr/>
+        </p:nvSpPr>
+        <p:spPr>
+          <a:xfrm>
+            <a:off x="11041380" y="5303520"/>
+            <a:ext cx="754380" cy="1508760"/>
+          </a:xfrm>
+          <a:prstGeom prst="rect">
+            <a:avLst/>
+          </a:prstGeom>
+          <a:noFill/>
+        </p:spPr>
+        <p:txBody>
+          <a:bodyPr wrap="square">
+            <a:spAutoFit/>
+          </a:bodyPr>
+          <a:lstStyle/>
+          <a:p>
+            <a:pPr algn="l"/>
+            <a:r>
+              <a:rPr sz="850" b="0" i="0">
+                <a:solidFill>
+                  <a:srgbClr val="BBBBBB"/>
+                </a:solidFill>
+              </a:rPr>
+              <a:t>Kabir distinguishes normal anger from Raudra.
+Confirms the core idea: Raudra = moral fury.
+Perfect quote to open or close a presentation.</a:t>
             </a:r>
           </a:p>
         </p:txBody>

</xml_diff>